<commit_message>
Update City Standard pricing to $250K/month
- City Standard: $450K → $250K/month
- ARR target: $54M → $30M
- Updated pitch deck and website

Co-Authored-By: Claude Opus 4.6 <noreply@anthropic.com>
</commit_message>
<xml_diff>
--- a/Swept_Pitch_Deck.pptx
+++ b/Swept_Pitch_Deck.pptx
@@ -3947,7 +3947,7 @@
                 <a:ea typeface="Arial Black" pitchFamily="34" charset="-122"/>
                 <a:cs typeface="Arial Black" pitchFamily="34" charset="-120"/>
               </a:rPr>
-              <a:t>$54M+</a:t>
+              <a:t>$30M+</a:t>
             </a:r>
             <a:endParaRPr lang="en-US" sz="2800" dirty="0"/>
           </a:p>
@@ -8965,7 +8965,7 @@
                 <a:ea typeface="Arial" pitchFamily="34" charset="-122"/>
                 <a:cs typeface="Arial" pitchFamily="34" charset="-120"/>
               </a:rPr>
-              <a:t>No new taxes required. $135K-$450K/mo per city.</a:t>
+              <a:t>No new taxes required. $135K-$250K/mo per city.</a:t>
             </a:r>
             <a:endParaRPr lang="en-US" sz="1100" dirty="0"/>
           </a:p>
@@ -9400,7 +9400,7 @@
                 <a:ea typeface="Arial" pitchFamily="34" charset="-122"/>
                 <a:cs typeface="Arial" pitchFamily="34" charset="-120"/>
               </a:rPr>
-              <a:t>At 10 cities, 5 zones each, $450K/month avg = $54M/year in revenue</a:t>
+              <a:t>At 10 cities, 5 zones each, $250K/month avg = $30M/year in revenue</a:t>
             </a:r>
             <a:endParaRPr lang="en-US" sz="1300" dirty="0"/>
           </a:p>
@@ -10054,7 +10054,7 @@
                 <a:ea typeface="Arial Black" pitchFamily="34" charset="-122"/>
                 <a:cs typeface="Arial Black" pitchFamily="34" charset="-120"/>
               </a:rPr>
-              <a:t>$450K</a:t>
+              <a:t>$250K</a:t>
             </a:r>
             <a:pPr algn="ctr" indent="0" marL="0">
               <a:buNone/>

</xml_diff>